<commit_message>
Dodanie przypadków testowych excel
</commit_message>
<xml_diff>
--- a/IO_2026_SGGW/docs/Prezentacja_projektu.pptx
+++ b/IO_2026_SGGW/docs/Prezentacja_projektu.pptx
@@ -5,20 +5,20 @@
     <p:sldMasterId id="2147483648" r:id="rId1"/>
   </p:sldMasterIdLst>
   <p:sldIdLst>
-    <p:sldId id="256" r:id="rId7"/>
-    <p:sldId id="257" r:id="rId8"/>
-    <p:sldId id="258" r:id="rId9"/>
-    <p:sldId id="259" r:id="rId10"/>
-    <p:sldId id="260" r:id="rId11"/>
-    <p:sldId id="261" r:id="rId12"/>
-    <p:sldId id="262" r:id="rId13"/>
-    <p:sldId id="263" r:id="rId14"/>
-    <p:sldId id="264" r:id="rId15"/>
-    <p:sldId id="265" r:id="rId16"/>
-    <p:sldId id="266" r:id="rId17"/>
-    <p:sldId id="267" r:id="rId18"/>
+    <p:sldId id="256" r:id="rId2"/>
+    <p:sldId id="257" r:id="rId3"/>
+    <p:sldId id="258" r:id="rId4"/>
+    <p:sldId id="259" r:id="rId5"/>
+    <p:sldId id="260" r:id="rId6"/>
+    <p:sldId id="261" r:id="rId7"/>
+    <p:sldId id="262" r:id="rId8"/>
+    <p:sldId id="263" r:id="rId9"/>
+    <p:sldId id="264" r:id="rId10"/>
+    <p:sldId id="265" r:id="rId11"/>
+    <p:sldId id="266" r:id="rId12"/>
+    <p:sldId id="267" r:id="rId13"/>
   </p:sldIdLst>
-  <p:sldSz cx="12191695" cy="6858000" type="screen4x3"/>
+  <p:sldSz cx="12192000" cy="6858000"/>
   <p:notesSz cx="6858000" cy="9144000"/>
   <p:defaultTextStyle>
     <a:defPPr>
@@ -115,6 +115,22 @@
       </a:defRPr>
     </a:lvl9pPr>
   </p:defaultTextStyle>
+  <p:extLst>
+    <p:ext uri="{EFAFB233-063F-42B5-8137-9DF3F51BA10A}">
+      <p15:sldGuideLst xmlns:p15="http://schemas.microsoft.com/office/powerpoint/2012/main">
+        <p15:guide id="1" orient="horz" pos="2160">
+          <p15:clr>
+            <a:srgbClr val="A4A3A4"/>
+          </p15:clr>
+        </p15:guide>
+        <p15:guide id="2" pos="2880">
+          <p15:clr>
+            <a:srgbClr val="A4A3A4"/>
+          </p15:clr>
+        </p15:guide>
+      </p15:sldGuideLst>
+    </p:ext>
+  </p:extLst>
 </p:presentation>
 </file>
 
@@ -156,10 +172,9 @@
           <a:lstStyle/>
           <a:p>
             <a:r>
-              <a:rPr lang="en-US" smtClean="0"/>
+              <a:rPr lang="en-US"/>
               <a:t>Click to edit Master title style</a:t>
             </a:r>
-            <a:endParaRPr lang="en-US"/>
           </a:p>
         </p:txBody>
       </p:sp>
@@ -275,10 +290,9 @@
           </a:lstStyle>
           <a:p>
             <a:r>
-              <a:rPr lang="en-US" smtClean="0"/>
+              <a:rPr lang="en-US"/>
               <a:t>Click to edit Master subtitle style</a:t>
             </a:r>
-            <a:endParaRPr lang="en-US"/>
           </a:p>
         </p:txBody>
       </p:sp>
@@ -299,7 +313,7 @@
           <a:p>
             <a:fld id="{5BCAD085-E8A6-8845-BD4E-CB4CCA059FC4}" type="datetimeFigureOut">
               <a:rPr lang="en-US" smtClean="0"/>
-              <a:t>1/27/13</a:t>
+              <a:t>6/29/2026</a:t>
             </a:fld>
             <a:endParaRPr lang="en-US"/>
           </a:p>
@@ -393,10 +407,9 @@
           <a:lstStyle/>
           <a:p>
             <a:r>
-              <a:rPr lang="en-US" smtClean="0"/>
+              <a:rPr lang="en-US"/>
               <a:t>Click to edit Master title style</a:t>
             </a:r>
-            <a:endParaRPr lang="en-US"/>
           </a:p>
         </p:txBody>
       </p:sp>
@@ -417,38 +430,37 @@
           <a:p>
             <a:pPr lvl="0"/>
             <a:r>
-              <a:rPr lang="en-US" smtClean="0"/>
+              <a:rPr lang="en-US"/>
               <a:t>Click to edit Master text styles</a:t>
             </a:r>
           </a:p>
           <a:p>
             <a:pPr lvl="1"/>
             <a:r>
-              <a:rPr lang="en-US" smtClean="0"/>
+              <a:rPr lang="en-US"/>
               <a:t>Second level</a:t>
             </a:r>
           </a:p>
           <a:p>
             <a:pPr lvl="2"/>
             <a:r>
-              <a:rPr lang="en-US" smtClean="0"/>
+              <a:rPr lang="en-US"/>
               <a:t>Third level</a:t>
             </a:r>
           </a:p>
           <a:p>
             <a:pPr lvl="3"/>
             <a:r>
-              <a:rPr lang="en-US" smtClean="0"/>
+              <a:rPr lang="en-US"/>
               <a:t>Fourth level</a:t>
             </a:r>
           </a:p>
           <a:p>
             <a:pPr lvl="4"/>
             <a:r>
-              <a:rPr lang="en-US" smtClean="0"/>
+              <a:rPr lang="en-US"/>
               <a:t>Fifth level</a:t>
             </a:r>
-            <a:endParaRPr lang="en-US"/>
           </a:p>
         </p:txBody>
       </p:sp>
@@ -469,7 +481,7 @@
           <a:p>
             <a:fld id="{5BCAD085-E8A6-8845-BD4E-CB4CCA059FC4}" type="datetimeFigureOut">
               <a:rPr lang="en-US" smtClean="0"/>
-              <a:t>1/27/13</a:t>
+              <a:t>6/29/2026</a:t>
             </a:fld>
             <a:endParaRPr lang="en-US"/>
           </a:p>
@@ -568,10 +580,9 @@
           <a:lstStyle/>
           <a:p>
             <a:r>
-              <a:rPr lang="en-US" smtClean="0"/>
+              <a:rPr lang="en-US"/>
               <a:t>Click to edit Master title style</a:t>
             </a:r>
-            <a:endParaRPr lang="en-US"/>
           </a:p>
         </p:txBody>
       </p:sp>
@@ -597,38 +608,37 @@
           <a:p>
             <a:pPr lvl="0"/>
             <a:r>
-              <a:rPr lang="en-US" smtClean="0"/>
+              <a:rPr lang="en-US"/>
               <a:t>Click to edit Master text styles</a:t>
             </a:r>
           </a:p>
           <a:p>
             <a:pPr lvl="1"/>
             <a:r>
-              <a:rPr lang="en-US" smtClean="0"/>
+              <a:rPr lang="en-US"/>
               <a:t>Second level</a:t>
             </a:r>
           </a:p>
           <a:p>
             <a:pPr lvl="2"/>
             <a:r>
-              <a:rPr lang="en-US" smtClean="0"/>
+              <a:rPr lang="en-US"/>
               <a:t>Third level</a:t>
             </a:r>
           </a:p>
           <a:p>
             <a:pPr lvl="3"/>
             <a:r>
-              <a:rPr lang="en-US" smtClean="0"/>
+              <a:rPr lang="en-US"/>
               <a:t>Fourth level</a:t>
             </a:r>
           </a:p>
           <a:p>
             <a:pPr lvl="4"/>
             <a:r>
-              <a:rPr lang="en-US" smtClean="0"/>
+              <a:rPr lang="en-US"/>
               <a:t>Fifth level</a:t>
             </a:r>
-            <a:endParaRPr lang="en-US"/>
           </a:p>
         </p:txBody>
       </p:sp>
@@ -649,7 +659,7 @@
           <a:p>
             <a:fld id="{5BCAD085-E8A6-8845-BD4E-CB4CCA059FC4}" type="datetimeFigureOut">
               <a:rPr lang="en-US" smtClean="0"/>
-              <a:t>1/27/13</a:t>
+              <a:t>6/29/2026</a:t>
             </a:fld>
             <a:endParaRPr lang="en-US"/>
           </a:p>
@@ -743,10 +753,9 @@
           <a:lstStyle/>
           <a:p>
             <a:r>
-              <a:rPr lang="en-US" smtClean="0"/>
+              <a:rPr lang="en-US"/>
               <a:t>Click to edit Master title style</a:t>
             </a:r>
-            <a:endParaRPr lang="en-US"/>
           </a:p>
         </p:txBody>
       </p:sp>
@@ -767,38 +776,37 @@
           <a:p>
             <a:pPr lvl="0"/>
             <a:r>
-              <a:rPr lang="en-US" smtClean="0"/>
+              <a:rPr lang="en-US"/>
               <a:t>Click to edit Master text styles</a:t>
             </a:r>
           </a:p>
           <a:p>
             <a:pPr lvl="1"/>
             <a:r>
-              <a:rPr lang="en-US" smtClean="0"/>
+              <a:rPr lang="en-US"/>
               <a:t>Second level</a:t>
             </a:r>
           </a:p>
           <a:p>
             <a:pPr lvl="2"/>
             <a:r>
-              <a:rPr lang="en-US" smtClean="0"/>
+              <a:rPr lang="en-US"/>
               <a:t>Third level</a:t>
             </a:r>
           </a:p>
           <a:p>
             <a:pPr lvl="3"/>
             <a:r>
-              <a:rPr lang="en-US" smtClean="0"/>
+              <a:rPr lang="en-US"/>
               <a:t>Fourth level</a:t>
             </a:r>
           </a:p>
           <a:p>
             <a:pPr lvl="4"/>
             <a:r>
-              <a:rPr lang="en-US" smtClean="0"/>
+              <a:rPr lang="en-US"/>
               <a:t>Fifth level</a:t>
             </a:r>
-            <a:endParaRPr lang="en-US"/>
           </a:p>
         </p:txBody>
       </p:sp>
@@ -819,7 +827,7 @@
           <a:p>
             <a:fld id="{5BCAD085-E8A6-8845-BD4E-CB4CCA059FC4}" type="datetimeFigureOut">
               <a:rPr lang="en-US" smtClean="0"/>
-              <a:t>1/27/13</a:t>
+              <a:t>6/29/2026</a:t>
             </a:fld>
             <a:endParaRPr lang="en-US"/>
           </a:p>
@@ -922,10 +930,9 @@
           </a:lstStyle>
           <a:p>
             <a:r>
-              <a:rPr lang="en-US" smtClean="0"/>
+              <a:rPr lang="en-US"/>
               <a:t>Click to edit Master title style</a:t>
             </a:r>
-            <a:endParaRPr lang="en-US"/>
           </a:p>
         </p:txBody>
       </p:sp>
@@ -1042,7 +1049,7 @@
           <a:p>
             <a:pPr lvl="0"/>
             <a:r>
-              <a:rPr lang="en-US" smtClean="0"/>
+              <a:rPr lang="en-US"/>
               <a:t>Click to edit Master text styles</a:t>
             </a:r>
           </a:p>
@@ -1065,7 +1072,7 @@
           <a:p>
             <a:fld id="{5BCAD085-E8A6-8845-BD4E-CB4CCA059FC4}" type="datetimeFigureOut">
               <a:rPr lang="en-US" smtClean="0"/>
-              <a:t>1/27/13</a:t>
+              <a:t>6/29/2026</a:t>
             </a:fld>
             <a:endParaRPr lang="en-US"/>
           </a:p>
@@ -1159,10 +1166,9 @@
           <a:lstStyle/>
           <a:p>
             <a:r>
-              <a:rPr lang="en-US" smtClean="0"/>
+              <a:rPr lang="en-US"/>
               <a:t>Click to edit Master title style</a:t>
             </a:r>
-            <a:endParaRPr lang="en-US"/>
           </a:p>
         </p:txBody>
       </p:sp>
@@ -1216,38 +1222,37 @@
           <a:p>
             <a:pPr lvl="0"/>
             <a:r>
-              <a:rPr lang="en-US" smtClean="0"/>
+              <a:rPr lang="en-US"/>
               <a:t>Click to edit Master text styles</a:t>
             </a:r>
           </a:p>
           <a:p>
             <a:pPr lvl="1"/>
             <a:r>
-              <a:rPr lang="en-US" smtClean="0"/>
+              <a:rPr lang="en-US"/>
               <a:t>Second level</a:t>
             </a:r>
           </a:p>
           <a:p>
             <a:pPr lvl="2"/>
             <a:r>
-              <a:rPr lang="en-US" smtClean="0"/>
+              <a:rPr lang="en-US"/>
               <a:t>Third level</a:t>
             </a:r>
           </a:p>
           <a:p>
             <a:pPr lvl="3"/>
             <a:r>
-              <a:rPr lang="en-US" smtClean="0"/>
+              <a:rPr lang="en-US"/>
               <a:t>Fourth level</a:t>
             </a:r>
           </a:p>
           <a:p>
             <a:pPr lvl="4"/>
             <a:r>
-              <a:rPr lang="en-US" smtClean="0"/>
+              <a:rPr lang="en-US"/>
               <a:t>Fifth level</a:t>
             </a:r>
-            <a:endParaRPr lang="en-US"/>
           </a:p>
         </p:txBody>
       </p:sp>
@@ -1301,38 +1306,37 @@
           <a:p>
             <a:pPr lvl="0"/>
             <a:r>
-              <a:rPr lang="en-US" smtClean="0"/>
+              <a:rPr lang="en-US"/>
               <a:t>Click to edit Master text styles</a:t>
             </a:r>
           </a:p>
           <a:p>
             <a:pPr lvl="1"/>
             <a:r>
-              <a:rPr lang="en-US" smtClean="0"/>
+              <a:rPr lang="en-US"/>
               <a:t>Second level</a:t>
             </a:r>
           </a:p>
           <a:p>
             <a:pPr lvl="2"/>
             <a:r>
-              <a:rPr lang="en-US" smtClean="0"/>
+              <a:rPr lang="en-US"/>
               <a:t>Third level</a:t>
             </a:r>
           </a:p>
           <a:p>
             <a:pPr lvl="3"/>
             <a:r>
-              <a:rPr lang="en-US" smtClean="0"/>
+              <a:rPr lang="en-US"/>
               <a:t>Fourth level</a:t>
             </a:r>
           </a:p>
           <a:p>
             <a:pPr lvl="4"/>
             <a:r>
-              <a:rPr lang="en-US" smtClean="0"/>
+              <a:rPr lang="en-US"/>
               <a:t>Fifth level</a:t>
             </a:r>
-            <a:endParaRPr lang="en-US"/>
           </a:p>
         </p:txBody>
       </p:sp>
@@ -1353,7 +1357,7 @@
           <a:p>
             <a:fld id="{5BCAD085-E8A6-8845-BD4E-CB4CCA059FC4}" type="datetimeFigureOut">
               <a:rPr lang="en-US" smtClean="0"/>
-              <a:t>1/27/13</a:t>
+              <a:t>6/29/2026</a:t>
             </a:fld>
             <a:endParaRPr lang="en-US"/>
           </a:p>
@@ -1451,10 +1455,9 @@
           </a:lstStyle>
           <a:p>
             <a:r>
-              <a:rPr lang="en-US" smtClean="0"/>
+              <a:rPr lang="en-US"/>
               <a:t>Click to edit Master title style</a:t>
             </a:r>
-            <a:endParaRPr lang="en-US"/>
           </a:p>
         </p:txBody>
       </p:sp>
@@ -1517,7 +1520,7 @@
           <a:p>
             <a:pPr lvl="0"/>
             <a:r>
-              <a:rPr lang="en-US" smtClean="0"/>
+              <a:rPr lang="en-US"/>
               <a:t>Click to edit Master text styles</a:t>
             </a:r>
           </a:p>
@@ -1573,38 +1576,37 @@
           <a:p>
             <a:pPr lvl="0"/>
             <a:r>
-              <a:rPr lang="en-US" smtClean="0"/>
+              <a:rPr lang="en-US"/>
               <a:t>Click to edit Master text styles</a:t>
             </a:r>
           </a:p>
           <a:p>
             <a:pPr lvl="1"/>
             <a:r>
-              <a:rPr lang="en-US" smtClean="0"/>
+              <a:rPr lang="en-US"/>
               <a:t>Second level</a:t>
             </a:r>
           </a:p>
           <a:p>
             <a:pPr lvl="2"/>
             <a:r>
-              <a:rPr lang="en-US" smtClean="0"/>
+              <a:rPr lang="en-US"/>
               <a:t>Third level</a:t>
             </a:r>
           </a:p>
           <a:p>
             <a:pPr lvl="3"/>
             <a:r>
-              <a:rPr lang="en-US" smtClean="0"/>
+              <a:rPr lang="en-US"/>
               <a:t>Fourth level</a:t>
             </a:r>
           </a:p>
           <a:p>
             <a:pPr lvl="4"/>
             <a:r>
-              <a:rPr lang="en-US" smtClean="0"/>
+              <a:rPr lang="en-US"/>
               <a:t>Fifth level</a:t>
             </a:r>
-            <a:endParaRPr lang="en-US"/>
           </a:p>
         </p:txBody>
       </p:sp>
@@ -1667,7 +1669,7 @@
           <a:p>
             <a:pPr lvl="0"/>
             <a:r>
-              <a:rPr lang="en-US" smtClean="0"/>
+              <a:rPr lang="en-US"/>
               <a:t>Click to edit Master text styles</a:t>
             </a:r>
           </a:p>
@@ -1723,38 +1725,37 @@
           <a:p>
             <a:pPr lvl="0"/>
             <a:r>
-              <a:rPr lang="en-US" smtClean="0"/>
+              <a:rPr lang="en-US"/>
               <a:t>Click to edit Master text styles</a:t>
             </a:r>
           </a:p>
           <a:p>
             <a:pPr lvl="1"/>
             <a:r>
-              <a:rPr lang="en-US" smtClean="0"/>
+              <a:rPr lang="en-US"/>
               <a:t>Second level</a:t>
             </a:r>
           </a:p>
           <a:p>
             <a:pPr lvl="2"/>
             <a:r>
-              <a:rPr lang="en-US" smtClean="0"/>
+              <a:rPr lang="en-US"/>
               <a:t>Third level</a:t>
             </a:r>
           </a:p>
           <a:p>
             <a:pPr lvl="3"/>
             <a:r>
-              <a:rPr lang="en-US" smtClean="0"/>
+              <a:rPr lang="en-US"/>
               <a:t>Fourth level</a:t>
             </a:r>
           </a:p>
           <a:p>
             <a:pPr lvl="4"/>
             <a:r>
-              <a:rPr lang="en-US" smtClean="0"/>
+              <a:rPr lang="en-US"/>
               <a:t>Fifth level</a:t>
             </a:r>
-            <a:endParaRPr lang="en-US"/>
           </a:p>
         </p:txBody>
       </p:sp>
@@ -1775,7 +1776,7 @@
           <a:p>
             <a:fld id="{5BCAD085-E8A6-8845-BD4E-CB4CCA059FC4}" type="datetimeFigureOut">
               <a:rPr lang="en-US" smtClean="0"/>
-              <a:t>1/27/13</a:t>
+              <a:t>6/29/2026</a:t>
             </a:fld>
             <a:endParaRPr lang="en-US"/>
           </a:p>
@@ -1869,10 +1870,9 @@
           <a:lstStyle/>
           <a:p>
             <a:r>
-              <a:rPr lang="en-US" smtClean="0"/>
+              <a:rPr lang="en-US"/>
               <a:t>Click to edit Master title style</a:t>
             </a:r>
-            <a:endParaRPr lang="en-US"/>
           </a:p>
         </p:txBody>
       </p:sp>
@@ -1893,7 +1893,7 @@
           <a:p>
             <a:fld id="{5BCAD085-E8A6-8845-BD4E-CB4CCA059FC4}" type="datetimeFigureOut">
               <a:rPr lang="en-US" smtClean="0"/>
-              <a:t>1/27/13</a:t>
+              <a:t>6/29/2026</a:t>
             </a:fld>
             <a:endParaRPr lang="en-US"/>
           </a:p>
@@ -1988,7 +1988,7 @@
           <a:p>
             <a:fld id="{5BCAD085-E8A6-8845-BD4E-CB4CCA059FC4}" type="datetimeFigureOut">
               <a:rPr lang="en-US" smtClean="0"/>
-              <a:t>1/27/13</a:t>
+              <a:t>6/29/2026</a:t>
             </a:fld>
             <a:endParaRPr lang="en-US"/>
           </a:p>
@@ -2091,10 +2091,9 @@
           </a:lstStyle>
           <a:p>
             <a:r>
-              <a:rPr lang="en-US" smtClean="0"/>
+              <a:rPr lang="en-US"/>
               <a:t>Click to edit Master title style</a:t>
             </a:r>
-            <a:endParaRPr lang="en-US"/>
           </a:p>
         </p:txBody>
       </p:sp>
@@ -2148,38 +2147,37 @@
           <a:p>
             <a:pPr lvl="0"/>
             <a:r>
-              <a:rPr lang="en-US" smtClean="0"/>
+              <a:rPr lang="en-US"/>
               <a:t>Click to edit Master text styles</a:t>
             </a:r>
           </a:p>
           <a:p>
             <a:pPr lvl="1"/>
             <a:r>
-              <a:rPr lang="en-US" smtClean="0"/>
+              <a:rPr lang="en-US"/>
               <a:t>Second level</a:t>
             </a:r>
           </a:p>
           <a:p>
             <a:pPr lvl="2"/>
             <a:r>
-              <a:rPr lang="en-US" smtClean="0"/>
+              <a:rPr lang="en-US"/>
               <a:t>Third level</a:t>
             </a:r>
           </a:p>
           <a:p>
             <a:pPr lvl="3"/>
             <a:r>
-              <a:rPr lang="en-US" smtClean="0"/>
+              <a:rPr lang="en-US"/>
               <a:t>Fourth level</a:t>
             </a:r>
           </a:p>
           <a:p>
             <a:pPr lvl="4"/>
             <a:r>
-              <a:rPr lang="en-US" smtClean="0"/>
+              <a:rPr lang="en-US"/>
               <a:t>Fifth level</a:t>
             </a:r>
-            <a:endParaRPr lang="en-US"/>
           </a:p>
         </p:txBody>
       </p:sp>
@@ -2242,7 +2240,7 @@
           <a:p>
             <a:pPr lvl="0"/>
             <a:r>
-              <a:rPr lang="en-US" smtClean="0"/>
+              <a:rPr lang="en-US"/>
               <a:t>Click to edit Master text styles</a:t>
             </a:r>
           </a:p>
@@ -2265,7 +2263,7 @@
           <a:p>
             <a:fld id="{5BCAD085-E8A6-8845-BD4E-CB4CCA059FC4}" type="datetimeFigureOut">
               <a:rPr lang="en-US" smtClean="0"/>
-              <a:t>1/27/13</a:t>
+              <a:t>6/29/2026</a:t>
             </a:fld>
             <a:endParaRPr lang="en-US"/>
           </a:p>
@@ -2368,10 +2366,9 @@
           </a:lstStyle>
           <a:p>
             <a:r>
-              <a:rPr lang="en-US" smtClean="0"/>
+              <a:rPr lang="en-US"/>
               <a:t>Click to edit Master title style</a:t>
             </a:r>
-            <a:endParaRPr lang="en-US"/>
           </a:p>
         </p:txBody>
       </p:sp>
@@ -2495,7 +2492,7 @@
           <a:p>
             <a:pPr lvl="0"/>
             <a:r>
-              <a:rPr lang="en-US" smtClean="0"/>
+              <a:rPr lang="en-US"/>
               <a:t>Click to edit Master text styles</a:t>
             </a:r>
           </a:p>
@@ -2518,7 +2515,7 @@
           <a:p>
             <a:fld id="{5BCAD085-E8A6-8845-BD4E-CB4CCA059FC4}" type="datetimeFigureOut">
               <a:rPr lang="en-US" smtClean="0"/>
-              <a:t>1/27/13</a:t>
+              <a:t>6/29/2026</a:t>
             </a:fld>
             <a:endParaRPr lang="en-US"/>
           </a:p>
@@ -2627,10 +2624,9 @@
           <a:lstStyle/>
           <a:p>
             <a:r>
-              <a:rPr lang="en-US" smtClean="0"/>
+              <a:rPr lang="en-US"/>
               <a:t>Click to edit Master title style</a:t>
             </a:r>
-            <a:endParaRPr lang="en-US"/>
           </a:p>
         </p:txBody>
       </p:sp>
@@ -2661,38 +2657,37 @@
           <a:p>
             <a:pPr lvl="0"/>
             <a:r>
-              <a:rPr lang="en-US" smtClean="0"/>
+              <a:rPr lang="en-US"/>
               <a:t>Click to edit Master text styles</a:t>
             </a:r>
           </a:p>
           <a:p>
             <a:pPr lvl="1"/>
             <a:r>
-              <a:rPr lang="en-US" smtClean="0"/>
+              <a:rPr lang="en-US"/>
               <a:t>Second level</a:t>
             </a:r>
           </a:p>
           <a:p>
             <a:pPr lvl="2"/>
             <a:r>
-              <a:rPr lang="en-US" smtClean="0"/>
+              <a:rPr lang="en-US"/>
               <a:t>Third level</a:t>
             </a:r>
           </a:p>
           <a:p>
             <a:pPr lvl="3"/>
             <a:r>
-              <a:rPr lang="en-US" smtClean="0"/>
+              <a:rPr lang="en-US"/>
               <a:t>Fourth level</a:t>
             </a:r>
           </a:p>
           <a:p>
             <a:pPr lvl="4"/>
             <a:r>
-              <a:rPr lang="en-US" smtClean="0"/>
+              <a:rPr lang="en-US"/>
               <a:t>Fifth level</a:t>
             </a:r>
-            <a:endParaRPr lang="en-US"/>
           </a:p>
         </p:txBody>
       </p:sp>
@@ -2731,7 +2726,7 @@
           <a:p>
             <a:fld id="{5BCAD085-E8A6-8845-BD4E-CB4CCA059FC4}" type="datetimeFigureOut">
               <a:rPr lang="en-US" smtClean="0"/>
-              <a:t>1/27/13</a:t>
+              <a:t>6/29/2026</a:t>
             </a:fld>
             <a:endParaRPr lang="en-US"/>
           </a:p>
@@ -3090,7 +3085,7 @@
 </file>
 
 <file path=ppt/slides/slide1.xml><?xml version="1.0" encoding="utf-8"?>
-<p:sld xmlns:a="http://schemas.openxmlformats.org/drawingml/2006/main" xmlns:p="http://schemas.openxmlformats.org/presentationml/2006/main" xmlns:r="http://schemas.openxmlformats.org/officeDocument/2006/relationships">
+<p:sld xmlns:a="http://schemas.openxmlformats.org/drawingml/2006/main" xmlns:r="http://schemas.openxmlformats.org/officeDocument/2006/relationships" xmlns:p="http://schemas.openxmlformats.org/presentationml/2006/main">
   <p:cSld>
     <p:spTree>
       <p:nvGrpSpPr>
@@ -3098,7 +3093,14 @@
         <p:cNvGrpSpPr/>
         <p:nvPr/>
       </p:nvGrpSpPr>
-      <p:grpSpPr/>
+      <p:grpSpPr>
+        <a:xfrm>
+          <a:off x="0" y="0"/>
+          <a:ext cx="0" cy="0"/>
+          <a:chOff x="0" y="0"/>
+          <a:chExt cx="0" cy="0"/>
+        </a:xfrm>
+      </p:grpSpPr>
       <p:sp>
         <p:nvSpPr>
           <p:cNvPr id="2" name="Rectangle 1"/>
@@ -3139,6 +3141,7 @@
           <a:lstStyle/>
           <a:p>
             <a:pPr algn="ctr"/>
+            <a:endParaRPr/>
           </a:p>
         </p:txBody>
       </p:sp>
@@ -3252,7 +3255,7 @@
 </file>
 
 <file path=ppt/slides/slide10.xml><?xml version="1.0" encoding="utf-8"?>
-<p:sld xmlns:a="http://schemas.openxmlformats.org/drawingml/2006/main" xmlns:p="http://schemas.openxmlformats.org/presentationml/2006/main" xmlns:r="http://schemas.openxmlformats.org/officeDocument/2006/relationships">
+<p:sld xmlns:a="http://schemas.openxmlformats.org/drawingml/2006/main" xmlns:r="http://schemas.openxmlformats.org/officeDocument/2006/relationships" xmlns:p="http://schemas.openxmlformats.org/presentationml/2006/main">
   <p:cSld>
     <p:spTree>
       <p:nvGrpSpPr>
@@ -3260,7 +3263,14 @@
         <p:cNvGrpSpPr/>
         <p:nvPr/>
       </p:nvGrpSpPr>
-      <p:grpSpPr/>
+      <p:grpSpPr>
+        <a:xfrm>
+          <a:off x="0" y="0"/>
+          <a:ext cx="0" cy="0"/>
+          <a:chOff x="0" y="0"/>
+          <a:chExt cx="0" cy="0"/>
+        </a:xfrm>
+      </p:grpSpPr>
       <p:sp>
         <p:nvSpPr>
           <p:cNvPr id="2" name="Rectangle 1"/>
@@ -3297,7 +3307,7 @@
           </a:fontRef>
         </p:style>
         <p:txBody>
-          <a:bodyPr rtlCol="0" anchor="ctr" lIns="457200" wrap="square"/>
+          <a:bodyPr wrap="square" lIns="457200" rtlCol="0" anchor="ctr"/>
           <a:lstStyle/>
           <a:p>
             <a:pPr algn="ctr"/>
@@ -3322,7 +3332,7 @@
         <p:spPr>
           <a:xfrm>
             <a:off x="640080" y="1325880"/>
-            <a:ext cx="10881360" cy="5212080"/>
+            <a:ext cx="10881360" cy="1669688"/>
           </a:xfrm>
           <a:prstGeom prst="rect">
             <a:avLst/>
@@ -3341,14 +3351,119 @@
               </a:spcAft>
             </a:pPr>
             <a:r>
-              <a:rPr sz="2000" b="0">
+              <a:rPr sz="2000" b="0" dirty="0">
                 <a:solidFill>
                   <a:srgbClr val="222222"/>
                 </a:solidFill>
                 <a:latin typeface="Segoe UI"/>
               </a:rPr>
-              <a:t>•  28 testów automatycznych (xUnit): jednostkowe i integracyjne</a:t>
-            </a:r>
+              <a:t>•  28 </a:t>
+            </a:r>
+            <a:r>
+              <a:rPr sz="2000" b="0" dirty="0" err="1">
+                <a:solidFill>
+                  <a:srgbClr val="222222"/>
+                </a:solidFill>
+                <a:latin typeface="Segoe UI"/>
+              </a:rPr>
+              <a:t>testów</a:t>
+            </a:r>
+            <a:r>
+              <a:rPr sz="2000" b="0" dirty="0">
+                <a:solidFill>
+                  <a:srgbClr val="222222"/>
+                </a:solidFill>
+                <a:latin typeface="Segoe UI"/>
+              </a:rPr>
+              <a:t> </a:t>
+            </a:r>
+            <a:r>
+              <a:rPr sz="2000" b="0" dirty="0" err="1">
+                <a:solidFill>
+                  <a:srgbClr val="222222"/>
+                </a:solidFill>
+                <a:latin typeface="Segoe UI"/>
+              </a:rPr>
+              <a:t>automatycznych</a:t>
+            </a:r>
+            <a:r>
+              <a:rPr sz="2000" b="0" dirty="0">
+                <a:solidFill>
+                  <a:srgbClr val="222222"/>
+                </a:solidFill>
+                <a:latin typeface="Segoe UI"/>
+              </a:rPr>
+              <a:t> (</a:t>
+            </a:r>
+            <a:r>
+              <a:rPr sz="2000" b="0" dirty="0" err="1">
+                <a:solidFill>
+                  <a:srgbClr val="222222"/>
+                </a:solidFill>
+                <a:latin typeface="Segoe UI"/>
+              </a:rPr>
+              <a:t>xUnit</a:t>
+            </a:r>
+            <a:r>
+              <a:rPr sz="2000" b="0" dirty="0">
+                <a:solidFill>
+                  <a:srgbClr val="222222"/>
+                </a:solidFill>
+                <a:latin typeface="Segoe UI"/>
+              </a:rPr>
+              <a:t>): </a:t>
+            </a:r>
+            <a:r>
+              <a:rPr sz="2000" b="0" dirty="0" err="1">
+                <a:solidFill>
+                  <a:srgbClr val="222222"/>
+                </a:solidFill>
+                <a:latin typeface="Segoe UI"/>
+              </a:rPr>
+              <a:t>jednostkowe</a:t>
+            </a:r>
+            <a:r>
+              <a:rPr sz="2000" b="0" dirty="0">
+                <a:solidFill>
+                  <a:srgbClr val="222222"/>
+                </a:solidFill>
+                <a:latin typeface="Segoe UI"/>
+              </a:rPr>
+              <a:t> </a:t>
+            </a:r>
+            <a:r>
+              <a:rPr sz="2000" b="0" dirty="0" err="1">
+                <a:solidFill>
+                  <a:srgbClr val="222222"/>
+                </a:solidFill>
+                <a:latin typeface="Segoe UI"/>
+              </a:rPr>
+              <a:t>i</a:t>
+            </a:r>
+            <a:r>
+              <a:rPr sz="2000" b="0" dirty="0">
+                <a:solidFill>
+                  <a:srgbClr val="222222"/>
+                </a:solidFill>
+                <a:latin typeface="Segoe UI"/>
+              </a:rPr>
+              <a:t> </a:t>
+            </a:r>
+            <a:r>
+              <a:rPr sz="2000" b="0" dirty="0" err="1">
+                <a:solidFill>
+                  <a:srgbClr val="222222"/>
+                </a:solidFill>
+                <a:latin typeface="Segoe UI"/>
+              </a:rPr>
+              <a:t>integracyjne</a:t>
+            </a:r>
+            <a:endParaRPr sz="2000" b="0" dirty="0">
+              <a:solidFill>
+                <a:srgbClr val="222222"/>
+              </a:solidFill>
+              <a:latin typeface="Segoe UI"/>
+            </a:endParaRPr>
           </a:p>
           <a:p>
             <a:pPr>
@@ -3357,46 +3472,65 @@
               </a:spcAft>
             </a:pPr>
             <a:r>
-              <a:rPr sz="2000" b="0">
+              <a:rPr sz="2000" b="0" dirty="0">
                 <a:solidFill>
                   <a:srgbClr val="222222"/>
                 </a:solidFill>
                 <a:latin typeface="Segoe UI"/>
               </a:rPr>
-              <a:t>•  Aktualnie 24/28 przechodzi</a:t>
-            </a:r>
-          </a:p>
-          <a:p>
-            <a:pPr lvl="1">
-              <a:spcAft>
-                <a:spcPts val="900"/>
-              </a:spcAft>
-            </a:pPr>
-            <a:r>
-              <a:rPr sz="1700" b="0">
+              <a:t>•  </a:t>
+            </a:r>
+            <a:r>
+              <a:rPr sz="2000" b="0" dirty="0" err="1">
                 <a:solidFill>
                   <a:srgbClr val="222222"/>
                 </a:solidFill>
                 <a:latin typeface="Segoe UI"/>
               </a:rPr>
-              <a:t>–  2 defekty formatowania kultury (do naprawy)</a:t>
-            </a:r>
-          </a:p>
-          <a:p>
-            <a:pPr lvl="1">
-              <a:spcAft>
-                <a:spcPts val="900"/>
-              </a:spcAft>
-            </a:pPr>
-            <a:r>
-              <a:rPr sz="1700" b="0">
+              <a:t>Aktualnie</a:t>
+            </a:r>
+            <a:r>
+              <a:rPr sz="2000" b="0" dirty="0">
                 <a:solidFill>
                   <a:srgbClr val="222222"/>
                 </a:solidFill>
                 <a:latin typeface="Segoe UI"/>
               </a:rPr>
-              <a:t>–  2 funkcje zaplanowane, w toku (bezpiecznik API, bool jako „1”)</a:t>
-            </a:r>
+              <a:t> 2</a:t>
+            </a:r>
+            <a:r>
+              <a:rPr lang="pl-PL" sz="2000" b="0" dirty="0">
+                <a:solidFill>
+                  <a:srgbClr val="222222"/>
+                </a:solidFill>
+                <a:latin typeface="Segoe UI"/>
+              </a:rPr>
+              <a:t>8</a:t>
+            </a:r>
+            <a:r>
+              <a:rPr sz="2000" b="0" dirty="0">
+                <a:solidFill>
+                  <a:srgbClr val="222222"/>
+                </a:solidFill>
+                <a:latin typeface="Segoe UI"/>
+              </a:rPr>
+              <a:t>/28 </a:t>
+            </a:r>
+            <a:r>
+              <a:rPr sz="2000" b="0" dirty="0" err="1">
+                <a:solidFill>
+                  <a:srgbClr val="222222"/>
+                </a:solidFill>
+                <a:latin typeface="Segoe UI"/>
+              </a:rPr>
+              <a:t>przechodzi</a:t>
+            </a:r>
+            <a:endParaRPr lang="pl-PL" sz="2000" b="0" dirty="0">
+              <a:solidFill>
+                <a:srgbClr val="222222"/>
+              </a:solidFill>
+              <a:latin typeface="Segoe UI"/>
+            </a:endParaRPr>
           </a:p>
           <a:p>
             <a:pPr>
@@ -3405,14 +3539,101 @@
               </a:spcAft>
             </a:pPr>
             <a:r>
-              <a:rPr sz="2000" b="0">
+              <a:rPr sz="2000" b="0" dirty="0">
                 <a:solidFill>
                   <a:srgbClr val="222222"/>
                 </a:solidFill>
                 <a:latin typeface="Segoe UI"/>
               </a:rPr>
-              <a:t>•  Dokumenty: scenariusze testowe + protokoły testowe</a:t>
-            </a:r>
+              <a:t>•  </a:t>
+            </a:r>
+            <a:r>
+              <a:rPr sz="2000" b="0" dirty="0" err="1">
+                <a:solidFill>
+                  <a:srgbClr val="222222"/>
+                </a:solidFill>
+                <a:latin typeface="Segoe UI"/>
+              </a:rPr>
+              <a:t>Dokumenty</a:t>
+            </a:r>
+            <a:r>
+              <a:rPr sz="2000" b="0" dirty="0">
+                <a:solidFill>
+                  <a:srgbClr val="222222"/>
+                </a:solidFill>
+                <a:latin typeface="Segoe UI"/>
+              </a:rPr>
+              <a:t>: </a:t>
+            </a:r>
+            <a:r>
+              <a:rPr sz="2000" b="0" dirty="0" err="1">
+                <a:solidFill>
+                  <a:srgbClr val="222222"/>
+                </a:solidFill>
+                <a:latin typeface="Segoe UI"/>
+              </a:rPr>
+              <a:t>scenariusze</a:t>
+            </a:r>
+            <a:r>
+              <a:rPr sz="2000" b="0" dirty="0">
+                <a:solidFill>
+                  <a:srgbClr val="222222"/>
+                </a:solidFill>
+                <a:latin typeface="Segoe UI"/>
+              </a:rPr>
+              <a:t> </a:t>
+            </a:r>
+            <a:r>
+              <a:rPr sz="2000" b="0" dirty="0" err="1">
+                <a:solidFill>
+                  <a:srgbClr val="222222"/>
+                </a:solidFill>
+                <a:latin typeface="Segoe UI"/>
+              </a:rPr>
+              <a:t>testowe</a:t>
+            </a:r>
+            <a:r>
+              <a:rPr sz="2000" b="0" dirty="0">
+                <a:solidFill>
+                  <a:srgbClr val="222222"/>
+                </a:solidFill>
+                <a:latin typeface="Segoe UI"/>
+              </a:rPr>
+              <a:t> + </a:t>
+            </a:r>
+            <a:r>
+              <a:rPr sz="2000" b="0" dirty="0" err="1">
+                <a:solidFill>
+                  <a:srgbClr val="222222"/>
+                </a:solidFill>
+                <a:latin typeface="Segoe UI"/>
+              </a:rPr>
+              <a:t>protokoły</a:t>
+            </a:r>
+            <a:r>
+              <a:rPr sz="2000" b="0" dirty="0">
+                <a:solidFill>
+                  <a:srgbClr val="222222"/>
+                </a:solidFill>
+                <a:latin typeface="Segoe UI"/>
+              </a:rPr>
+              <a:t> </a:t>
+            </a:r>
+            <a:r>
+              <a:rPr sz="2000" b="0" dirty="0" err="1">
+                <a:solidFill>
+                  <a:srgbClr val="222222"/>
+                </a:solidFill>
+                <a:latin typeface="Segoe UI"/>
+              </a:rPr>
+              <a:t>testowe</a:t>
+            </a:r>
+            <a:endParaRPr sz="2000" b="0" dirty="0">
+              <a:solidFill>
+                <a:srgbClr val="222222"/>
+              </a:solidFill>
+              <a:latin typeface="Segoe UI"/>
+            </a:endParaRPr>
           </a:p>
           <a:p>
             <a:pPr>
@@ -3421,13 +3642,49 @@
               </a:spcAft>
             </a:pPr>
             <a:r>
-              <a:rPr sz="2000" b="0">
+              <a:rPr sz="2000" b="0" dirty="0">
                 <a:solidFill>
                   <a:srgbClr val="222222"/>
                 </a:solidFill>
                 <a:latin typeface="Segoe UI"/>
               </a:rPr>
-              <a:t>•  Dokumentacja API w Doxygen (HTML)</a:t>
+              <a:t>•  </a:t>
+            </a:r>
+            <a:r>
+              <a:rPr sz="2000" b="0" dirty="0" err="1">
+                <a:solidFill>
+                  <a:srgbClr val="222222"/>
+                </a:solidFill>
+                <a:latin typeface="Segoe UI"/>
+              </a:rPr>
+              <a:t>Dokumentacja</a:t>
+            </a:r>
+            <a:r>
+              <a:rPr sz="2000" b="0" dirty="0">
+                <a:solidFill>
+                  <a:srgbClr val="222222"/>
+                </a:solidFill>
+                <a:latin typeface="Segoe UI"/>
+              </a:rPr>
+              <a:t> API w </a:t>
+            </a:r>
+            <a:r>
+              <a:rPr sz="2000" b="0" dirty="0" err="1">
+                <a:solidFill>
+                  <a:srgbClr val="222222"/>
+                </a:solidFill>
+                <a:latin typeface="Segoe UI"/>
+              </a:rPr>
+              <a:t>Doxygen</a:t>
+            </a:r>
+            <a:r>
+              <a:rPr sz="2000" b="0" dirty="0">
+                <a:solidFill>
+                  <a:srgbClr val="222222"/>
+                </a:solidFill>
+                <a:latin typeface="Segoe UI"/>
+              </a:rPr>
+              <a:t> (HTML)</a:t>
             </a:r>
           </a:p>
         </p:txBody>
@@ -3441,7 +3698,7 @@
 </file>
 
 <file path=ppt/slides/slide11.xml><?xml version="1.0" encoding="utf-8"?>
-<p:sld xmlns:a="http://schemas.openxmlformats.org/drawingml/2006/main" xmlns:p="http://schemas.openxmlformats.org/presentationml/2006/main" xmlns:r="http://schemas.openxmlformats.org/officeDocument/2006/relationships">
+<p:sld xmlns:a="http://schemas.openxmlformats.org/drawingml/2006/main" xmlns:r="http://schemas.openxmlformats.org/officeDocument/2006/relationships" xmlns:p="http://schemas.openxmlformats.org/presentationml/2006/main">
   <p:cSld>
     <p:spTree>
       <p:nvGrpSpPr>
@@ -3449,7 +3706,14 @@
         <p:cNvGrpSpPr/>
         <p:nvPr/>
       </p:nvGrpSpPr>
-      <p:grpSpPr/>
+      <p:grpSpPr>
+        <a:xfrm>
+          <a:off x="0" y="0"/>
+          <a:ext cx="0" cy="0"/>
+          <a:chOff x="0" y="0"/>
+          <a:chExt cx="0" cy="0"/>
+        </a:xfrm>
+      </p:grpSpPr>
       <p:sp>
         <p:nvSpPr>
           <p:cNvPr id="2" name="Rectangle 1"/>
@@ -3486,7 +3750,7 @@
           </a:fontRef>
         </p:style>
         <p:txBody>
-          <a:bodyPr rtlCol="0" anchor="ctr" lIns="457200" wrap="square"/>
+          <a:bodyPr wrap="square" lIns="457200" rtlCol="0" anchor="ctr"/>
           <a:lstStyle/>
           <a:p>
             <a:pPr algn="ctr"/>
@@ -3521,9 +3785,27 @@
                 <a:tableStyleId>{5C22544A-7EE6-4342-B048-85BDC9FD1C3A}</a:tableStyleId>
               </a:tblPr>
               <a:tblGrid>
-                <a:gridCol w="2743200"/>
-                <a:gridCol w="2377440"/>
-                <a:gridCol w="5760720"/>
+                <a:gridCol w="2743200">
+                  <a:extLst>
+                    <a:ext uri="{9D8B030D-6E8A-4147-A177-3AD203B41FA5}">
+                      <a16:colId xmlns:a16="http://schemas.microsoft.com/office/drawing/2014/main" val="20000"/>
+                    </a:ext>
+                  </a:extLst>
+                </a:gridCol>
+                <a:gridCol w="2377440">
+                  <a:extLst>
+                    <a:ext uri="{9D8B030D-6E8A-4147-A177-3AD203B41FA5}">
+                      <a16:colId xmlns:a16="http://schemas.microsoft.com/office/drawing/2014/main" val="20001"/>
+                    </a:ext>
+                  </a:extLst>
+                </a:gridCol>
+                <a:gridCol w="5760720">
+                  <a:extLst>
+                    <a:ext uri="{9D8B030D-6E8A-4147-A177-3AD203B41FA5}">
+                      <a16:colId xmlns:a16="http://schemas.microsoft.com/office/drawing/2014/main" val="20002"/>
+                    </a:ext>
+                  </a:extLst>
+                </a:gridCol>
               </a:tblGrid>
               <a:tr h="320040">
                 <a:tc>
@@ -3592,6 +3874,11 @@
                     </a:solidFill>
                   </a:tcPr>
                 </a:tc>
+                <a:extLst>
+                  <a:ext uri="{0D108BD9-81ED-4DB2-BD59-A6C34878D82A}">
+                    <a16:rowId xmlns:a16="http://schemas.microsoft.com/office/drawing/2014/main" val="10000"/>
+                  </a:ext>
+                </a:extLst>
               </a:tr>
               <a:tr h="320040">
                 <a:tc>
@@ -3660,6 +3947,11 @@
                     </a:solidFill>
                   </a:tcPr>
                 </a:tc>
+                <a:extLst>
+                  <a:ext uri="{0D108BD9-81ED-4DB2-BD59-A6C34878D82A}">
+                    <a16:rowId xmlns:a16="http://schemas.microsoft.com/office/drawing/2014/main" val="10001"/>
+                  </a:ext>
+                </a:extLst>
               </a:tr>
               <a:tr h="320040">
                 <a:tc>
@@ -3728,6 +4020,11 @@
                     </a:solidFill>
                   </a:tcPr>
                 </a:tc>
+                <a:extLst>
+                  <a:ext uri="{0D108BD9-81ED-4DB2-BD59-A6C34878D82A}">
+                    <a16:rowId xmlns:a16="http://schemas.microsoft.com/office/drawing/2014/main" val="10002"/>
+                  </a:ext>
+                </a:extLst>
               </a:tr>
               <a:tr h="320040">
                 <a:tc>
@@ -3796,6 +4093,11 @@
                     </a:solidFill>
                   </a:tcPr>
                 </a:tc>
+                <a:extLst>
+                  <a:ext uri="{0D108BD9-81ED-4DB2-BD59-A6C34878D82A}">
+                    <a16:rowId xmlns:a16="http://schemas.microsoft.com/office/drawing/2014/main" val="10003"/>
+                  </a:ext>
+                </a:extLst>
               </a:tr>
               <a:tr h="320040">
                 <a:tc>
@@ -3864,6 +4166,11 @@
                     </a:solidFill>
                   </a:tcPr>
                 </a:tc>
+                <a:extLst>
+                  <a:ext uri="{0D108BD9-81ED-4DB2-BD59-A6C34878D82A}">
+                    <a16:rowId xmlns:a16="http://schemas.microsoft.com/office/drawing/2014/main" val="10004"/>
+                  </a:ext>
+                </a:extLst>
               </a:tr>
               <a:tr h="320040">
                 <a:tc>
@@ -3932,6 +4239,11 @@
                     </a:solidFill>
                   </a:tcPr>
                 </a:tc>
+                <a:extLst>
+                  <a:ext uri="{0D108BD9-81ED-4DB2-BD59-A6C34878D82A}">
+                    <a16:rowId xmlns:a16="http://schemas.microsoft.com/office/drawing/2014/main" val="10005"/>
+                  </a:ext>
+                </a:extLst>
               </a:tr>
               <a:tr h="320040">
                 <a:tc>
@@ -4000,6 +4312,11 @@
                     </a:solidFill>
                   </a:tcPr>
                 </a:tc>
+                <a:extLst>
+                  <a:ext uri="{0D108BD9-81ED-4DB2-BD59-A6C34878D82A}">
+                    <a16:rowId xmlns:a16="http://schemas.microsoft.com/office/drawing/2014/main" val="10006"/>
+                  </a:ext>
+                </a:extLst>
               </a:tr>
               <a:tr h="320040">
                 <a:tc>
@@ -4068,6 +4385,11 @@
                     </a:solidFill>
                   </a:tcPr>
                 </a:tc>
+                <a:extLst>
+                  <a:ext uri="{0D108BD9-81ED-4DB2-BD59-A6C34878D82A}">
+                    <a16:rowId xmlns:a16="http://schemas.microsoft.com/office/drawing/2014/main" val="10007"/>
+                  </a:ext>
+                </a:extLst>
               </a:tr>
               <a:tr h="320040">
                 <a:tc>
@@ -4136,6 +4458,11 @@
                     </a:solidFill>
                   </a:tcPr>
                 </a:tc>
+                <a:extLst>
+                  <a:ext uri="{0D108BD9-81ED-4DB2-BD59-A6C34878D82A}">
+                    <a16:rowId xmlns:a16="http://schemas.microsoft.com/office/drawing/2014/main" val="10008"/>
+                  </a:ext>
+                </a:extLst>
               </a:tr>
               <a:tr h="320040">
                 <a:tc>
@@ -4204,6 +4531,11 @@
                     </a:solidFill>
                   </a:tcPr>
                 </a:tc>
+                <a:extLst>
+                  <a:ext uri="{0D108BD9-81ED-4DB2-BD59-A6C34878D82A}">
+                    <a16:rowId xmlns:a16="http://schemas.microsoft.com/office/drawing/2014/main" val="10009"/>
+                  </a:ext>
+                </a:extLst>
               </a:tr>
               <a:tr h="320040">
                 <a:tc>
@@ -4272,6 +4604,11 @@
                     </a:solidFill>
                   </a:tcPr>
                 </a:tc>
+                <a:extLst>
+                  <a:ext uri="{0D108BD9-81ED-4DB2-BD59-A6C34878D82A}">
+                    <a16:rowId xmlns:a16="http://schemas.microsoft.com/office/drawing/2014/main" val="10010"/>
+                  </a:ext>
+                </a:extLst>
               </a:tr>
               <a:tr h="320040">
                 <a:tc>
@@ -4340,6 +4677,11 @@
                     </a:solidFill>
                   </a:tcPr>
                 </a:tc>
+                <a:extLst>
+                  <a:ext uri="{0D108BD9-81ED-4DB2-BD59-A6C34878D82A}">
+                    <a16:rowId xmlns:a16="http://schemas.microsoft.com/office/drawing/2014/main" val="10011"/>
+                  </a:ext>
+                </a:extLst>
               </a:tr>
               <a:tr h="320040">
                 <a:tc>
@@ -4408,6 +4750,11 @@
                     </a:solidFill>
                   </a:tcPr>
                 </a:tc>
+                <a:extLst>
+                  <a:ext uri="{0D108BD9-81ED-4DB2-BD59-A6C34878D82A}">
+                    <a16:rowId xmlns:a16="http://schemas.microsoft.com/office/drawing/2014/main" val="10012"/>
+                  </a:ext>
+                </a:extLst>
               </a:tr>
               <a:tr h="320040">
                 <a:tc>
@@ -4476,6 +4823,11 @@
                     </a:solidFill>
                   </a:tcPr>
                 </a:tc>
+                <a:extLst>
+                  <a:ext uri="{0D108BD9-81ED-4DB2-BD59-A6C34878D82A}">
+                    <a16:rowId xmlns:a16="http://schemas.microsoft.com/office/drawing/2014/main" val="10013"/>
+                  </a:ext>
+                </a:extLst>
               </a:tr>
               <a:tr h="320040">
                 <a:tc>
@@ -4544,6 +4896,11 @@
                     </a:solidFill>
                   </a:tcPr>
                 </a:tc>
+                <a:extLst>
+                  <a:ext uri="{0D108BD9-81ED-4DB2-BD59-A6C34878D82A}">
+                    <a16:rowId xmlns:a16="http://schemas.microsoft.com/office/drawing/2014/main" val="10014"/>
+                  </a:ext>
+                </a:extLst>
               </a:tr>
               <a:tr h="320040">
                 <a:tc>
@@ -4612,6 +4969,11 @@
                     </a:solidFill>
                   </a:tcPr>
                 </a:tc>
+                <a:extLst>
+                  <a:ext uri="{0D108BD9-81ED-4DB2-BD59-A6C34878D82A}">
+                    <a16:rowId xmlns:a16="http://schemas.microsoft.com/office/drawing/2014/main" val="10015"/>
+                  </a:ext>
+                </a:extLst>
               </a:tr>
             </a:tbl>
           </a:graphicData>
@@ -4626,7 +4988,7 @@
 </file>
 
 <file path=ppt/slides/slide12.xml><?xml version="1.0" encoding="utf-8"?>
-<p:sld xmlns:a="http://schemas.openxmlformats.org/drawingml/2006/main" xmlns:p="http://schemas.openxmlformats.org/presentationml/2006/main" xmlns:r="http://schemas.openxmlformats.org/officeDocument/2006/relationships">
+<p:sld xmlns:a="http://schemas.openxmlformats.org/drawingml/2006/main" xmlns:r="http://schemas.openxmlformats.org/officeDocument/2006/relationships" xmlns:p="http://schemas.openxmlformats.org/presentationml/2006/main">
   <p:cSld>
     <p:spTree>
       <p:nvGrpSpPr>
@@ -4634,7 +4996,14 @@
         <p:cNvGrpSpPr/>
         <p:nvPr/>
       </p:nvGrpSpPr>
-      <p:grpSpPr/>
+      <p:grpSpPr>
+        <a:xfrm>
+          <a:off x="0" y="0"/>
+          <a:ext cx="0" cy="0"/>
+          <a:chOff x="0" y="0"/>
+          <a:chExt cx="0" cy="0"/>
+        </a:xfrm>
+      </p:grpSpPr>
       <p:sp>
         <p:nvSpPr>
           <p:cNvPr id="2" name="Rectangle 1"/>
@@ -4671,7 +5040,7 @@
           </a:fontRef>
         </p:style>
         <p:txBody>
-          <a:bodyPr rtlCol="0" anchor="ctr" lIns="457200" wrap="square"/>
+          <a:bodyPr wrap="square" lIns="457200" rtlCol="0" anchor="ctr"/>
           <a:lstStyle/>
           <a:p>
             <a:pPr algn="ctr"/>
@@ -4783,7 +5152,7 @@
 </file>
 
 <file path=ppt/slides/slide2.xml><?xml version="1.0" encoding="utf-8"?>
-<p:sld xmlns:a="http://schemas.openxmlformats.org/drawingml/2006/main" xmlns:p="http://schemas.openxmlformats.org/presentationml/2006/main" xmlns:r="http://schemas.openxmlformats.org/officeDocument/2006/relationships">
+<p:sld xmlns:a="http://schemas.openxmlformats.org/drawingml/2006/main" xmlns:r="http://schemas.openxmlformats.org/officeDocument/2006/relationships" xmlns:p="http://schemas.openxmlformats.org/presentationml/2006/main">
   <p:cSld>
     <p:spTree>
       <p:nvGrpSpPr>
@@ -4791,7 +5160,14 @@
         <p:cNvGrpSpPr/>
         <p:nvPr/>
       </p:nvGrpSpPr>
-      <p:grpSpPr/>
+      <p:grpSpPr>
+        <a:xfrm>
+          <a:off x="0" y="0"/>
+          <a:ext cx="0" cy="0"/>
+          <a:chOff x="0" y="0"/>
+          <a:chExt cx="0" cy="0"/>
+        </a:xfrm>
+      </p:grpSpPr>
       <p:sp>
         <p:nvSpPr>
           <p:cNvPr id="2" name="Rectangle 1"/>
@@ -4828,7 +5204,7 @@
           </a:fontRef>
         </p:style>
         <p:txBody>
-          <a:bodyPr rtlCol="0" anchor="ctr" lIns="457200" wrap="square"/>
+          <a:bodyPr wrap="square" lIns="457200" rtlCol="0" anchor="ctr"/>
           <a:lstStyle/>
           <a:p>
             <a:pPr algn="ctr"/>
@@ -4924,7 +5300,7 @@
 </file>
 
 <file path=ppt/slides/slide3.xml><?xml version="1.0" encoding="utf-8"?>
-<p:sld xmlns:a="http://schemas.openxmlformats.org/drawingml/2006/main" xmlns:p="http://schemas.openxmlformats.org/presentationml/2006/main" xmlns:r="http://schemas.openxmlformats.org/officeDocument/2006/relationships">
+<p:sld xmlns:a="http://schemas.openxmlformats.org/drawingml/2006/main" xmlns:r="http://schemas.openxmlformats.org/officeDocument/2006/relationships" xmlns:p="http://schemas.openxmlformats.org/presentationml/2006/main">
   <p:cSld>
     <p:spTree>
       <p:nvGrpSpPr>
@@ -4932,7 +5308,14 @@
         <p:cNvGrpSpPr/>
         <p:nvPr/>
       </p:nvGrpSpPr>
-      <p:grpSpPr/>
+      <p:grpSpPr>
+        <a:xfrm>
+          <a:off x="0" y="0"/>
+          <a:ext cx="0" cy="0"/>
+          <a:chOff x="0" y="0"/>
+          <a:chExt cx="0" cy="0"/>
+        </a:xfrm>
+      </p:grpSpPr>
       <p:sp>
         <p:nvSpPr>
           <p:cNvPr id="2" name="Rectangle 1"/>
@@ -4969,7 +5352,7 @@
           </a:fontRef>
         </p:style>
         <p:txBody>
-          <a:bodyPr rtlCol="0" anchor="ctr" lIns="457200" wrap="square"/>
+          <a:bodyPr wrap="square" lIns="457200" rtlCol="0" anchor="ctr"/>
           <a:lstStyle/>
           <a:p>
             <a:pPr algn="ctr"/>
@@ -5113,7 +5496,7 @@
 </file>
 
 <file path=ppt/slides/slide4.xml><?xml version="1.0" encoding="utf-8"?>
-<p:sld xmlns:a="http://schemas.openxmlformats.org/drawingml/2006/main" xmlns:p="http://schemas.openxmlformats.org/presentationml/2006/main" xmlns:r="http://schemas.openxmlformats.org/officeDocument/2006/relationships">
+<p:sld xmlns:a="http://schemas.openxmlformats.org/drawingml/2006/main" xmlns:r="http://schemas.openxmlformats.org/officeDocument/2006/relationships" xmlns:p="http://schemas.openxmlformats.org/presentationml/2006/main">
   <p:cSld>
     <p:spTree>
       <p:nvGrpSpPr>
@@ -5121,7 +5504,14 @@
         <p:cNvGrpSpPr/>
         <p:nvPr/>
       </p:nvGrpSpPr>
-      <p:grpSpPr/>
+      <p:grpSpPr>
+        <a:xfrm>
+          <a:off x="0" y="0"/>
+          <a:ext cx="0" cy="0"/>
+          <a:chOff x="0" y="0"/>
+          <a:chExt cx="0" cy="0"/>
+        </a:xfrm>
+      </p:grpSpPr>
       <p:sp>
         <p:nvSpPr>
           <p:cNvPr id="2" name="Rectangle 1"/>
@@ -5158,7 +5548,7 @@
           </a:fontRef>
         </p:style>
         <p:txBody>
-          <a:bodyPr rtlCol="0" anchor="ctr" lIns="457200" wrap="square"/>
+          <a:bodyPr wrap="square" lIns="457200" rtlCol="0" anchor="ctr"/>
           <a:lstStyle/>
           <a:p>
             <a:pPr algn="ctr"/>
@@ -5286,7 +5676,7 @@
 </file>
 
 <file path=ppt/slides/slide5.xml><?xml version="1.0" encoding="utf-8"?>
-<p:sld xmlns:a="http://schemas.openxmlformats.org/drawingml/2006/main" xmlns:p="http://schemas.openxmlformats.org/presentationml/2006/main" xmlns:r="http://schemas.openxmlformats.org/officeDocument/2006/relationships">
+<p:sld xmlns:a="http://schemas.openxmlformats.org/drawingml/2006/main" xmlns:r="http://schemas.openxmlformats.org/officeDocument/2006/relationships" xmlns:p="http://schemas.openxmlformats.org/presentationml/2006/main">
   <p:cSld>
     <p:spTree>
       <p:nvGrpSpPr>
@@ -5294,7 +5684,14 @@
         <p:cNvGrpSpPr/>
         <p:nvPr/>
       </p:nvGrpSpPr>
-      <p:grpSpPr/>
+      <p:grpSpPr>
+        <a:xfrm>
+          <a:off x="0" y="0"/>
+          <a:ext cx="0" cy="0"/>
+          <a:chOff x="0" y="0"/>
+          <a:chExt cx="0" cy="0"/>
+        </a:xfrm>
+      </p:grpSpPr>
       <p:sp>
         <p:nvSpPr>
           <p:cNvPr id="2" name="Rectangle 1"/>
@@ -5331,7 +5728,7 @@
           </a:fontRef>
         </p:style>
         <p:txBody>
-          <a:bodyPr rtlCol="0" anchor="ctr" lIns="457200" wrap="square"/>
+          <a:bodyPr wrap="square" lIns="457200" rtlCol="0" anchor="ctr"/>
           <a:lstStyle/>
           <a:p>
             <a:pPr algn="ctr"/>
@@ -5415,7 +5812,7 @@
 </file>
 
 <file path=ppt/slides/slide6.xml><?xml version="1.0" encoding="utf-8"?>
-<p:sld xmlns:a="http://schemas.openxmlformats.org/drawingml/2006/main" xmlns:p="http://schemas.openxmlformats.org/presentationml/2006/main" xmlns:r="http://schemas.openxmlformats.org/officeDocument/2006/relationships">
+<p:sld xmlns:a="http://schemas.openxmlformats.org/drawingml/2006/main" xmlns:r="http://schemas.openxmlformats.org/officeDocument/2006/relationships" xmlns:p="http://schemas.openxmlformats.org/presentationml/2006/main">
   <p:cSld>
     <p:spTree>
       <p:nvGrpSpPr>
@@ -5423,7 +5820,14 @@
         <p:cNvGrpSpPr/>
         <p:nvPr/>
       </p:nvGrpSpPr>
-      <p:grpSpPr/>
+      <p:grpSpPr>
+        <a:xfrm>
+          <a:off x="0" y="0"/>
+          <a:ext cx="0" cy="0"/>
+          <a:chOff x="0" y="0"/>
+          <a:chExt cx="0" cy="0"/>
+        </a:xfrm>
+      </p:grpSpPr>
       <p:sp>
         <p:nvSpPr>
           <p:cNvPr id="2" name="Rectangle 1"/>
@@ -5460,7 +5864,7 @@
           </a:fontRef>
         </p:style>
         <p:txBody>
-          <a:bodyPr rtlCol="0" anchor="ctr" lIns="457200" wrap="square"/>
+          <a:bodyPr wrap="square" lIns="457200" rtlCol="0" anchor="ctr"/>
           <a:lstStyle/>
           <a:p>
             <a:pPr algn="ctr"/>
@@ -5652,7 +6056,7 @@
 </file>
 
 <file path=ppt/slides/slide7.xml><?xml version="1.0" encoding="utf-8"?>
-<p:sld xmlns:a="http://schemas.openxmlformats.org/drawingml/2006/main" xmlns:p="http://schemas.openxmlformats.org/presentationml/2006/main" xmlns:r="http://schemas.openxmlformats.org/officeDocument/2006/relationships">
+<p:sld xmlns:a="http://schemas.openxmlformats.org/drawingml/2006/main" xmlns:r="http://schemas.openxmlformats.org/officeDocument/2006/relationships" xmlns:p="http://schemas.openxmlformats.org/presentationml/2006/main">
   <p:cSld>
     <p:spTree>
       <p:nvGrpSpPr>
@@ -5660,7 +6064,14 @@
         <p:cNvGrpSpPr/>
         <p:nvPr/>
       </p:nvGrpSpPr>
-      <p:grpSpPr/>
+      <p:grpSpPr>
+        <a:xfrm>
+          <a:off x="0" y="0"/>
+          <a:ext cx="0" cy="0"/>
+          <a:chOff x="0" y="0"/>
+          <a:chExt cx="0" cy="0"/>
+        </a:xfrm>
+      </p:grpSpPr>
       <p:sp>
         <p:nvSpPr>
           <p:cNvPr id="2" name="Rectangle 1"/>
@@ -5697,7 +6108,7 @@
           </a:fontRef>
         </p:style>
         <p:txBody>
-          <a:bodyPr rtlCol="0" anchor="ctr" lIns="457200" wrap="square"/>
+          <a:bodyPr wrap="square" lIns="457200" rtlCol="0" anchor="ctr"/>
           <a:lstStyle/>
           <a:p>
             <a:pPr algn="ctr"/>
@@ -5781,7 +6192,7 @@
 </file>
 
 <file path=ppt/slides/slide8.xml><?xml version="1.0" encoding="utf-8"?>
-<p:sld xmlns:a="http://schemas.openxmlformats.org/drawingml/2006/main" xmlns:p="http://schemas.openxmlformats.org/presentationml/2006/main" xmlns:r="http://schemas.openxmlformats.org/officeDocument/2006/relationships">
+<p:sld xmlns:a="http://schemas.openxmlformats.org/drawingml/2006/main" xmlns:r="http://schemas.openxmlformats.org/officeDocument/2006/relationships" xmlns:p="http://schemas.openxmlformats.org/presentationml/2006/main">
   <p:cSld>
     <p:spTree>
       <p:nvGrpSpPr>
@@ -5789,7 +6200,14 @@
         <p:cNvGrpSpPr/>
         <p:nvPr/>
       </p:nvGrpSpPr>
-      <p:grpSpPr/>
+      <p:grpSpPr>
+        <a:xfrm>
+          <a:off x="0" y="0"/>
+          <a:ext cx="0" cy="0"/>
+          <a:chOff x="0" y="0"/>
+          <a:chExt cx="0" cy="0"/>
+        </a:xfrm>
+      </p:grpSpPr>
       <p:sp>
         <p:nvSpPr>
           <p:cNvPr id="2" name="Rectangle 1"/>
@@ -5826,7 +6244,7 @@
           </a:fontRef>
         </p:style>
         <p:txBody>
-          <a:bodyPr rtlCol="0" anchor="ctr" lIns="457200" wrap="square"/>
+          <a:bodyPr wrap="square" lIns="457200" rtlCol="0" anchor="ctr"/>
           <a:lstStyle/>
           <a:p>
             <a:pPr algn="ctr"/>
@@ -5910,7 +6328,7 @@
 </file>
 
 <file path=ppt/slides/slide9.xml><?xml version="1.0" encoding="utf-8"?>
-<p:sld xmlns:a="http://schemas.openxmlformats.org/drawingml/2006/main" xmlns:p="http://schemas.openxmlformats.org/presentationml/2006/main" xmlns:r="http://schemas.openxmlformats.org/officeDocument/2006/relationships">
+<p:sld xmlns:a="http://schemas.openxmlformats.org/drawingml/2006/main" xmlns:r="http://schemas.openxmlformats.org/officeDocument/2006/relationships" xmlns:p="http://schemas.openxmlformats.org/presentationml/2006/main">
   <p:cSld>
     <p:spTree>
       <p:nvGrpSpPr>
@@ -5918,7 +6336,14 @@
         <p:cNvGrpSpPr/>
         <p:nvPr/>
       </p:nvGrpSpPr>
-      <p:grpSpPr/>
+      <p:grpSpPr>
+        <a:xfrm>
+          <a:off x="0" y="0"/>
+          <a:ext cx="0" cy="0"/>
+          <a:chOff x="0" y="0"/>
+          <a:chExt cx="0" cy="0"/>
+        </a:xfrm>
+      </p:grpSpPr>
       <p:sp>
         <p:nvSpPr>
           <p:cNvPr id="2" name="Rectangle 1"/>
@@ -5955,7 +6380,7 @@
           </a:fontRef>
         </p:style>
         <p:txBody>
-          <a:bodyPr rtlCol="0" anchor="ctr" lIns="457200" wrap="square"/>
+          <a:bodyPr wrap="square" lIns="457200" rtlCol="0" anchor="ctr"/>
           <a:lstStyle/>
           <a:p>
             <a:pPr algn="ctr"/>

</xml_diff>